<commit_message>
update intro supplemental slides
</commit_message>
<xml_diff>
--- a/assets/ppt/intro/in1-supplemental.pptx
+++ b/assets/ppt/intro/in1-supplemental.pptx
@@ -5,18 +5,19 @@
     <p:sldMasterId id="2147483700" r:id="rId1"/>
   </p:sldMasterIdLst>
   <p:notesMasterIdLst>
-    <p:notesMasterId r:id="rId11"/>
+    <p:notesMasterId r:id="rId12"/>
   </p:notesMasterIdLst>
   <p:sldIdLst>
     <p:sldId id="277" r:id="rId2"/>
     <p:sldId id="278" r:id="rId3"/>
     <p:sldId id="279" r:id="rId4"/>
-    <p:sldId id="280" r:id="rId5"/>
-    <p:sldId id="281" r:id="rId6"/>
-    <p:sldId id="282" r:id="rId7"/>
-    <p:sldId id="283" r:id="rId8"/>
-    <p:sldId id="284" r:id="rId9"/>
-    <p:sldId id="285" r:id="rId10"/>
+    <p:sldId id="286" r:id="rId5"/>
+    <p:sldId id="280" r:id="rId6"/>
+    <p:sldId id="281" r:id="rId7"/>
+    <p:sldId id="282" r:id="rId8"/>
+    <p:sldId id="283" r:id="rId9"/>
+    <p:sldId id="284" r:id="rId10"/>
+    <p:sldId id="285" r:id="rId11"/>
   </p:sldIdLst>
   <p:sldSz cx="9144000" cy="5143500" type="screen16x9"/>
   <p:notesSz cx="6858000" cy="9144000"/>
@@ -1279,7 +1280,7 @@
           <a:p>
             <a:fld id="{031950AD-E443-1743-A459-21F1AAF6F81A}" type="datetime1">
               <a:rPr lang="en-CA" smtClean="0"/>
-              <a:t>2020-09-10</a:t>
+              <a:t>2025-05-11</a:t>
             </a:fld>
             <a:endParaRPr lang="en-US"/>
           </a:p>
@@ -1477,7 +1478,7 @@
           <a:p>
             <a:fld id="{06378DE7-32B7-DE46-BFEF-C88F96B6CB46}" type="datetime1">
               <a:rPr lang="en-CA" smtClean="0"/>
-              <a:t>2020-09-10</a:t>
+              <a:t>2025-05-11</a:t>
             </a:fld>
             <a:endParaRPr lang="en-US"/>
           </a:p>
@@ -1685,7 +1686,7 @@
           <a:p>
             <a:fld id="{E9DA3F3E-97D7-E44B-928F-428312F41925}" type="datetime1">
               <a:rPr lang="en-CA" smtClean="0"/>
-              <a:t>2020-09-10</a:t>
+              <a:t>2025-05-11</a:t>
             </a:fld>
             <a:endParaRPr lang="en-US"/>
           </a:p>
@@ -2035,7 +2036,7 @@
           <a:p>
             <a:fld id="{B8239F57-6224-5A48-B5A0-8B41CBC82DE5}" type="datetime1">
               <a:rPr lang="en-CA" smtClean="0"/>
-              <a:t>2020-09-10</a:t>
+              <a:t>2025-05-11</a:t>
             </a:fld>
             <a:endParaRPr lang="en-US"/>
           </a:p>
@@ -2310,7 +2311,7 @@
           <a:p>
             <a:fld id="{82B3F797-7154-BC4F-9D0E-5EAD5AEED6D6}" type="datetime1">
               <a:rPr lang="en-CA" smtClean="0"/>
-              <a:t>2020-09-10</a:t>
+              <a:t>2025-05-11</a:t>
             </a:fld>
             <a:endParaRPr lang="en-US"/>
           </a:p>
@@ -2575,7 +2576,7 @@
           <a:p>
             <a:fld id="{3097AE3F-C575-B946-9624-8F064FF29641}" type="datetime1">
               <a:rPr lang="en-CA" smtClean="0"/>
-              <a:t>2020-09-10</a:t>
+              <a:t>2025-05-11</a:t>
             </a:fld>
             <a:endParaRPr lang="en-US"/>
           </a:p>
@@ -2987,7 +2988,7 @@
           <a:p>
             <a:fld id="{FCF57352-CE81-D949-8615-D94A6D43C5AB}" type="datetime1">
               <a:rPr lang="en-CA" smtClean="0"/>
-              <a:t>2020-09-10</a:t>
+              <a:t>2025-05-11</a:t>
             </a:fld>
             <a:endParaRPr lang="en-US"/>
           </a:p>
@@ -3128,7 +3129,7 @@
           <a:p>
             <a:fld id="{5644584D-0879-4C43-9A33-9262212C8909}" type="datetime1">
               <a:rPr lang="en-CA" smtClean="0"/>
-              <a:t>2020-09-10</a:t>
+              <a:t>2025-05-11</a:t>
             </a:fld>
             <a:endParaRPr lang="en-US"/>
           </a:p>
@@ -3241,7 +3242,7 @@
           <a:p>
             <a:fld id="{1EF55C8E-3F84-9742-9F0E-FF66F4EE05BA}" type="datetime1">
               <a:rPr lang="en-CA" smtClean="0"/>
-              <a:t>2020-09-10</a:t>
+              <a:t>2025-05-11</a:t>
             </a:fld>
             <a:endParaRPr lang="en-US"/>
           </a:p>
@@ -3552,7 +3553,7 @@
           <a:p>
             <a:fld id="{9F487085-DD22-E94F-A745-BA3BAACACBF9}" type="datetime1">
               <a:rPr lang="en-CA" smtClean="0"/>
-              <a:t>2020-09-10</a:t>
+              <a:t>2025-05-11</a:t>
             </a:fld>
             <a:endParaRPr lang="en-US"/>
           </a:p>
@@ -3840,7 +3841,7 @@
           <a:p>
             <a:fld id="{DF553C96-34AC-1447-87E6-A53840AE668C}" type="datetime1">
               <a:rPr lang="en-CA" smtClean="0"/>
-              <a:t>2020-09-10</a:t>
+              <a:t>2025-05-11</a:t>
             </a:fld>
             <a:endParaRPr lang="en-US"/>
           </a:p>
@@ -4081,7 +4082,7 @@
           <a:p>
             <a:fld id="{478D0DE7-FBBE-9D43-9800-3DF9B4EF63B2}" type="datetime1">
               <a:rPr lang="en-CA" smtClean="0"/>
-              <a:t>2020-09-10</a:t>
+              <a:t>2025-05-11</a:t>
             </a:fld>
             <a:endParaRPr lang="en-US"/>
           </a:p>
@@ -4737,6 +4738,123 @@
 </p:sld>
 </file>
 
+<file path=ppt/slides/slide10.xml><?xml version="1.0" encoding="utf-8"?>
+<p:sld xmlns:a="http://schemas.openxmlformats.org/drawingml/2006/main" xmlns:r="http://schemas.openxmlformats.org/officeDocument/2006/relationships" xmlns:p="http://schemas.openxmlformats.org/presentationml/2006/main">
+  <p:cSld>
+    <p:spTree>
+      <p:nvGrpSpPr>
+        <p:cNvPr id="1" name=""/>
+        <p:cNvGrpSpPr/>
+        <p:nvPr/>
+      </p:nvGrpSpPr>
+      <p:grpSpPr>
+        <a:xfrm>
+          <a:off x="0" y="0"/>
+          <a:ext cx="0" cy="0"/>
+          <a:chOff x="0" y="0"/>
+          <a:chExt cx="0" cy="0"/>
+        </a:xfrm>
+      </p:grpSpPr>
+      <p:sp>
+        <p:nvSpPr>
+          <p:cNvPr id="2" name="Title 1">
+            <a:extLst>
+              <a:ext uri="{FF2B5EF4-FFF2-40B4-BE49-F238E27FC236}">
+                <a16:creationId xmlns:a16="http://schemas.microsoft.com/office/drawing/2014/main" id="{F1AAA65C-C553-2549-9B79-EFECA68317AF}"/>
+              </a:ext>
+            </a:extLst>
+          </p:cNvPr>
+          <p:cNvSpPr>
+            <a:spLocks noGrp="1"/>
+          </p:cNvSpPr>
+          <p:nvPr>
+            <p:ph type="title"/>
+          </p:nvPr>
+        </p:nvSpPr>
+        <p:spPr/>
+        <p:txBody>
+          <a:bodyPr/>
+          <a:lstStyle/>
+          <a:p>
+            <a:r>
+              <a:rPr lang="en-US" dirty="0"/>
+              <a:t>Don’t take this course if you are this guy:</a:t>
+            </a:r>
+          </a:p>
+        </p:txBody>
+      </p:sp>
+      <p:sp>
+        <p:nvSpPr>
+          <p:cNvPr id="3" name="Slide Number Placeholder 2">
+            <a:extLst>
+              <a:ext uri="{FF2B5EF4-FFF2-40B4-BE49-F238E27FC236}">
+                <a16:creationId xmlns:a16="http://schemas.microsoft.com/office/drawing/2014/main" id="{2CF9610F-0EAB-1C4E-9033-C97A005E561E}"/>
+              </a:ext>
+            </a:extLst>
+          </p:cNvPr>
+          <p:cNvSpPr>
+            <a:spLocks noGrp="1"/>
+          </p:cNvSpPr>
+          <p:nvPr>
+            <p:ph type="sldNum" sz="quarter" idx="12"/>
+          </p:nvPr>
+        </p:nvSpPr>
+        <p:spPr/>
+        <p:txBody>
+          <a:bodyPr/>
+          <a:lstStyle/>
+          <a:p>
+            <a:fld id="{7B252BF6-6A9C-D04A-BBE8-37A07D64A1C3}" type="slidenum">
+              <a:rPr lang="en-US" smtClean="0"/>
+              <a:t>10</a:t>
+            </a:fld>
+            <a:endParaRPr lang="en-US"/>
+          </a:p>
+        </p:txBody>
+      </p:sp>
+      <p:pic>
+        <p:nvPicPr>
+          <p:cNvPr id="5" name="Picture 4" descr="A picture containing food&#10;&#10;Description automatically generated">
+            <a:extLst>
+              <a:ext uri="{FF2B5EF4-FFF2-40B4-BE49-F238E27FC236}">
+                <a16:creationId xmlns:a16="http://schemas.microsoft.com/office/drawing/2014/main" id="{F4304FBC-C6C8-EF42-BF81-71820728544D}"/>
+              </a:ext>
+            </a:extLst>
+          </p:cNvPr>
+          <p:cNvPicPr>
+            <a:picLocks noChangeAspect="1"/>
+          </p:cNvPicPr>
+          <p:nvPr/>
+        </p:nvPicPr>
+        <p:blipFill>
+          <a:blip r:embed="rId2"/>
+          <a:stretch>
+            <a:fillRect/>
+          </a:stretch>
+        </p:blipFill>
+        <p:spPr>
+          <a:xfrm>
+            <a:off x="0" y="1268016"/>
+            <a:ext cx="9144000" cy="3159707"/>
+          </a:xfrm>
+          <a:prstGeom prst="rect">
+            <a:avLst/>
+          </a:prstGeom>
+        </p:spPr>
+      </p:pic>
+    </p:spTree>
+    <p:extLst>
+      <p:ext uri="{BB962C8B-B14F-4D97-AF65-F5344CB8AC3E}">
+        <p14:creationId xmlns:p14="http://schemas.microsoft.com/office/powerpoint/2010/main" val="425193230"/>
+      </p:ext>
+    </p:extLst>
+  </p:cSld>
+  <p:clrMapOvr>
+    <a:masterClrMapping/>
+  </p:clrMapOvr>
+</p:sld>
+</file>
+
 <file path=ppt/slides/slide2.xml><?xml version="1.0" encoding="utf-8"?>
 <p:sld xmlns:a="http://schemas.openxmlformats.org/drawingml/2006/main" xmlns:r="http://schemas.openxmlformats.org/officeDocument/2006/relationships" xmlns:p="http://schemas.openxmlformats.org/presentationml/2006/main">
   <p:cSld>
@@ -4948,6 +5066,129 @@
   <p:cSld>
     <p:spTree>
       <p:nvGrpSpPr>
+        <p:cNvPr id="1" name="">
+          <a:extLst>
+            <a:ext uri="{FF2B5EF4-FFF2-40B4-BE49-F238E27FC236}">
+              <a16:creationId xmlns:a16="http://schemas.microsoft.com/office/drawing/2014/main" id="{8A38EDC7-D240-BC13-84C4-7B97ED44024F}"/>
+            </a:ext>
+          </a:extLst>
+        </p:cNvPr>
+        <p:cNvGrpSpPr/>
+        <p:nvPr/>
+      </p:nvGrpSpPr>
+      <p:grpSpPr>
+        <a:xfrm>
+          <a:off x="0" y="0"/>
+          <a:ext cx="0" cy="0"/>
+          <a:chOff x="0" y="0"/>
+          <a:chExt cx="0" cy="0"/>
+        </a:xfrm>
+      </p:grpSpPr>
+      <p:sp>
+        <p:nvSpPr>
+          <p:cNvPr id="2" name="Title 1">
+            <a:extLst>
+              <a:ext uri="{FF2B5EF4-FFF2-40B4-BE49-F238E27FC236}">
+                <a16:creationId xmlns:a16="http://schemas.microsoft.com/office/drawing/2014/main" id="{70BA028C-A613-A4B6-1659-44A3BEC0D95A}"/>
+              </a:ext>
+            </a:extLst>
+          </p:cNvPr>
+          <p:cNvSpPr>
+            <a:spLocks noGrp="1"/>
+          </p:cNvSpPr>
+          <p:nvPr>
+            <p:ph type="title"/>
+          </p:nvPr>
+        </p:nvSpPr>
+        <p:spPr/>
+        <p:txBody>
+          <a:bodyPr/>
+          <a:lstStyle/>
+          <a:p>
+            <a:r>
+              <a:rPr lang="en-US" dirty="0"/>
+              <a:t>Rate my Professor</a:t>
+            </a:r>
+          </a:p>
+        </p:txBody>
+      </p:sp>
+      <p:sp>
+        <p:nvSpPr>
+          <p:cNvPr id="3" name="Slide Number Placeholder 2">
+            <a:extLst>
+              <a:ext uri="{FF2B5EF4-FFF2-40B4-BE49-F238E27FC236}">
+                <a16:creationId xmlns:a16="http://schemas.microsoft.com/office/drawing/2014/main" id="{B5F63608-07AD-BB62-C5EF-7BEF4DE121BD}"/>
+              </a:ext>
+            </a:extLst>
+          </p:cNvPr>
+          <p:cNvSpPr>
+            <a:spLocks noGrp="1"/>
+          </p:cNvSpPr>
+          <p:nvPr>
+            <p:ph type="sldNum" sz="quarter" idx="12"/>
+          </p:nvPr>
+        </p:nvSpPr>
+        <p:spPr/>
+        <p:txBody>
+          <a:bodyPr/>
+          <a:lstStyle/>
+          <a:p>
+            <a:fld id="{7B252BF6-6A9C-D04A-BBE8-37A07D64A1C3}" type="slidenum">
+              <a:rPr lang="en-US" smtClean="0"/>
+              <a:t>4</a:t>
+            </a:fld>
+            <a:endParaRPr lang="en-US"/>
+          </a:p>
+        </p:txBody>
+      </p:sp>
+      <p:pic>
+        <p:nvPicPr>
+          <p:cNvPr id="6" name="Picture 5">
+            <a:extLst>
+              <a:ext uri="{FF2B5EF4-FFF2-40B4-BE49-F238E27FC236}">
+                <a16:creationId xmlns:a16="http://schemas.microsoft.com/office/drawing/2014/main" id="{BC6A571D-00DC-CB24-8FC6-0F2B0631E4C0}"/>
+              </a:ext>
+            </a:extLst>
+          </p:cNvPr>
+          <p:cNvPicPr>
+            <a:picLocks noChangeAspect="1"/>
+          </p:cNvPicPr>
+          <p:nvPr/>
+        </p:nvPicPr>
+        <p:blipFill>
+          <a:blip r:embed="rId2"/>
+          <a:stretch>
+            <a:fillRect/>
+          </a:stretch>
+        </p:blipFill>
+        <p:spPr>
+          <a:xfrm>
+            <a:off x="445974" y="1540243"/>
+            <a:ext cx="8252052" cy="2063013"/>
+          </a:xfrm>
+          <a:prstGeom prst="rect">
+            <a:avLst/>
+          </a:prstGeom>
+        </p:spPr>
+      </p:pic>
+    </p:spTree>
+    <p:extLst>
+      <p:ext uri="{BB962C8B-B14F-4D97-AF65-F5344CB8AC3E}">
+        <p14:creationId xmlns:p14="http://schemas.microsoft.com/office/powerpoint/2010/main" val="1204557650"/>
+      </p:ext>
+    </p:extLst>
+  </p:cSld>
+  <p:clrMapOvr>
+    <a:masterClrMapping/>
+  </p:clrMapOvr>
+</p:sld>
+</file>
+
+<file path=ppt/slides/slide5.xml><?xml version="1.0" encoding="utf-8"?>
+<p:sld xmlns:a="http://schemas.openxmlformats.org/drawingml/2006/main" xmlns:r="http://schemas.openxmlformats.org/officeDocument/2006/relationships" xmlns:p="http://schemas.openxmlformats.org/presentationml/2006/main">
+  <p:cSld>
+    <p:spTree>
+      <p:nvGrpSpPr>
         <p:cNvPr id="1" name=""/>
         <p:cNvGrpSpPr/>
         <p:nvPr/>
@@ -5011,7 +5252,7 @@
           <a:p>
             <a:fld id="{7B252BF6-6A9C-D04A-BBE8-37A07D64A1C3}" type="slidenum">
               <a:rPr lang="en-US" smtClean="0"/>
-              <a:t>4</a:t>
+              <a:t>5</a:t>
             </a:fld>
             <a:endParaRPr lang="en-US"/>
           </a:p>
@@ -5060,7 +5301,7 @@
 </p:sld>
 </file>
 
-<file path=ppt/slides/slide5.xml><?xml version="1.0" encoding="utf-8"?>
+<file path=ppt/slides/slide6.xml><?xml version="1.0" encoding="utf-8"?>
 <p:sld xmlns:a="http://schemas.openxmlformats.org/drawingml/2006/main" xmlns:r="http://schemas.openxmlformats.org/officeDocument/2006/relationships" xmlns:p="http://schemas.openxmlformats.org/presentationml/2006/main">
   <p:cSld>
     <p:spTree>
@@ -5128,7 +5369,7 @@
           <a:p>
             <a:fld id="{7B252BF6-6A9C-D04A-BBE8-37A07D64A1C3}" type="slidenum">
               <a:rPr lang="en-US" smtClean="0"/>
-              <a:t>5</a:t>
+              <a:t>6</a:t>
             </a:fld>
             <a:endParaRPr lang="en-US"/>
           </a:p>
@@ -5177,7 +5418,7 @@
 </p:sld>
 </file>
 
-<file path=ppt/slides/slide6.xml><?xml version="1.0" encoding="utf-8"?>
+<file path=ppt/slides/slide7.xml><?xml version="1.0" encoding="utf-8"?>
 <p:sld xmlns:a="http://schemas.openxmlformats.org/drawingml/2006/main" xmlns:r="http://schemas.openxmlformats.org/officeDocument/2006/relationships" xmlns:p="http://schemas.openxmlformats.org/presentationml/2006/main">
   <p:cSld>
     <p:spTree>
@@ -5245,7 +5486,7 @@
           <a:p>
             <a:fld id="{7B252BF6-6A9C-D04A-BBE8-37A07D64A1C3}" type="slidenum">
               <a:rPr lang="en-US" smtClean="0"/>
-              <a:t>6</a:t>
+              <a:t>7</a:t>
             </a:fld>
             <a:endParaRPr lang="en-US"/>
           </a:p>
@@ -5294,7 +5535,7 @@
 </p:sld>
 </file>
 
-<file path=ppt/slides/slide7.xml><?xml version="1.0" encoding="utf-8"?>
+<file path=ppt/slides/slide8.xml><?xml version="1.0" encoding="utf-8"?>
 <p:sld xmlns:a="http://schemas.openxmlformats.org/drawingml/2006/main" xmlns:r="http://schemas.openxmlformats.org/officeDocument/2006/relationships" xmlns:p="http://schemas.openxmlformats.org/presentationml/2006/main">
   <p:cSld>
     <p:spTree>
@@ -5362,7 +5603,7 @@
           <a:p>
             <a:fld id="{7B252BF6-6A9C-D04A-BBE8-37A07D64A1C3}" type="slidenum">
               <a:rPr lang="en-US" smtClean="0"/>
-              <a:t>7</a:t>
+              <a:t>8</a:t>
             </a:fld>
             <a:endParaRPr lang="en-US"/>
           </a:p>
@@ -5411,7 +5652,7 @@
 </p:sld>
 </file>
 
-<file path=ppt/slides/slide8.xml><?xml version="1.0" encoding="utf-8"?>
+<file path=ppt/slides/slide9.xml><?xml version="1.0" encoding="utf-8"?>
 <p:sld xmlns:a="http://schemas.openxmlformats.org/drawingml/2006/main" xmlns:r="http://schemas.openxmlformats.org/officeDocument/2006/relationships" xmlns:p="http://schemas.openxmlformats.org/presentationml/2006/main">
   <p:cSld>
     <p:spTree>
@@ -5479,7 +5720,7 @@
           <a:p>
             <a:fld id="{7B252BF6-6A9C-D04A-BBE8-37A07D64A1C3}" type="slidenum">
               <a:rPr lang="en-US" smtClean="0"/>
-              <a:t>8</a:t>
+              <a:t>9</a:t>
             </a:fld>
             <a:endParaRPr lang="en-US"/>
           </a:p>
@@ -5519,123 +5760,6 @@
     <p:extLst>
       <p:ext uri="{BB962C8B-B14F-4D97-AF65-F5344CB8AC3E}">
         <p14:creationId xmlns:p14="http://schemas.microsoft.com/office/powerpoint/2010/main" val="2934561854"/>
-      </p:ext>
-    </p:extLst>
-  </p:cSld>
-  <p:clrMapOvr>
-    <a:masterClrMapping/>
-  </p:clrMapOvr>
-</p:sld>
-</file>
-
-<file path=ppt/slides/slide9.xml><?xml version="1.0" encoding="utf-8"?>
-<p:sld xmlns:a="http://schemas.openxmlformats.org/drawingml/2006/main" xmlns:r="http://schemas.openxmlformats.org/officeDocument/2006/relationships" xmlns:p="http://schemas.openxmlformats.org/presentationml/2006/main">
-  <p:cSld>
-    <p:spTree>
-      <p:nvGrpSpPr>
-        <p:cNvPr id="1" name=""/>
-        <p:cNvGrpSpPr/>
-        <p:nvPr/>
-      </p:nvGrpSpPr>
-      <p:grpSpPr>
-        <a:xfrm>
-          <a:off x="0" y="0"/>
-          <a:ext cx="0" cy="0"/>
-          <a:chOff x="0" y="0"/>
-          <a:chExt cx="0" cy="0"/>
-        </a:xfrm>
-      </p:grpSpPr>
-      <p:sp>
-        <p:nvSpPr>
-          <p:cNvPr id="2" name="Title 1">
-            <a:extLst>
-              <a:ext uri="{FF2B5EF4-FFF2-40B4-BE49-F238E27FC236}">
-                <a16:creationId xmlns:a16="http://schemas.microsoft.com/office/drawing/2014/main" id="{F1AAA65C-C553-2549-9B79-EFECA68317AF}"/>
-              </a:ext>
-            </a:extLst>
-          </p:cNvPr>
-          <p:cNvSpPr>
-            <a:spLocks noGrp="1"/>
-          </p:cNvSpPr>
-          <p:nvPr>
-            <p:ph type="title"/>
-          </p:nvPr>
-        </p:nvSpPr>
-        <p:spPr/>
-        <p:txBody>
-          <a:bodyPr/>
-          <a:lstStyle/>
-          <a:p>
-            <a:r>
-              <a:rPr lang="en-US" dirty="0"/>
-              <a:t>Don’t take this course if you are this guy:</a:t>
-            </a:r>
-          </a:p>
-        </p:txBody>
-      </p:sp>
-      <p:sp>
-        <p:nvSpPr>
-          <p:cNvPr id="3" name="Slide Number Placeholder 2">
-            <a:extLst>
-              <a:ext uri="{FF2B5EF4-FFF2-40B4-BE49-F238E27FC236}">
-                <a16:creationId xmlns:a16="http://schemas.microsoft.com/office/drawing/2014/main" id="{2CF9610F-0EAB-1C4E-9033-C97A005E561E}"/>
-              </a:ext>
-            </a:extLst>
-          </p:cNvPr>
-          <p:cNvSpPr>
-            <a:spLocks noGrp="1"/>
-          </p:cNvSpPr>
-          <p:nvPr>
-            <p:ph type="sldNum" sz="quarter" idx="12"/>
-          </p:nvPr>
-        </p:nvSpPr>
-        <p:spPr/>
-        <p:txBody>
-          <a:bodyPr/>
-          <a:lstStyle/>
-          <a:p>
-            <a:fld id="{7B252BF6-6A9C-D04A-BBE8-37A07D64A1C3}" type="slidenum">
-              <a:rPr lang="en-US" smtClean="0"/>
-              <a:t>9</a:t>
-            </a:fld>
-            <a:endParaRPr lang="en-US"/>
-          </a:p>
-        </p:txBody>
-      </p:sp>
-      <p:pic>
-        <p:nvPicPr>
-          <p:cNvPr id="5" name="Picture 4" descr="A picture containing food&#10;&#10;Description automatically generated">
-            <a:extLst>
-              <a:ext uri="{FF2B5EF4-FFF2-40B4-BE49-F238E27FC236}">
-                <a16:creationId xmlns:a16="http://schemas.microsoft.com/office/drawing/2014/main" id="{F4304FBC-C6C8-EF42-BF81-71820728544D}"/>
-              </a:ext>
-            </a:extLst>
-          </p:cNvPr>
-          <p:cNvPicPr>
-            <a:picLocks noChangeAspect="1"/>
-          </p:cNvPicPr>
-          <p:nvPr/>
-        </p:nvPicPr>
-        <p:blipFill>
-          <a:blip r:embed="rId2"/>
-          <a:stretch>
-            <a:fillRect/>
-          </a:stretch>
-        </p:blipFill>
-        <p:spPr>
-          <a:xfrm>
-            <a:off x="0" y="1268016"/>
-            <a:ext cx="9144000" cy="3159707"/>
-          </a:xfrm>
-          <a:prstGeom prst="rect">
-            <a:avLst/>
-          </a:prstGeom>
-        </p:spPr>
-      </p:pic>
-    </p:spTree>
-    <p:extLst>
-      <p:ext uri="{BB962C8B-B14F-4D97-AF65-F5344CB8AC3E}">
-        <p14:creationId xmlns:p14="http://schemas.microsoft.com/office/powerpoint/2010/main" val="425193230"/>
       </p:ext>
     </p:extLst>
   </p:cSld>

</xml_diff>